<commit_message>
chore(output): regenerate v5.1/v5.2 color variants with fact-check fixes
Rebuild charcoal and midnight variants on top of corrected content.py
(A1 citation format, A5 author name, B5 chip label, B7 arch note)

Co-Authored-By: Claude Sonnet 4.6 <noreply@anthropic.com>
</commit_message>
<xml_diff>
--- a/output/network-card-csi-v5.1-charcoal.pptx
+++ b/output/network-card-csi-v5.1-charcoal.pptx
@@ -5133,7 +5133,7 @@
             <a:avLst/>
           </a:prstGeom>
           <a:solidFill>
-            <a:srgbClr val="4A6FA5"/>
+            <a:srgbClr val="2E7DD1"/>
           </a:solidFill>
           <a:ln>
             <a:noFill/>
@@ -5212,7 +5212,7 @@
           </a:prstGeom>
           <a:ln w="25400">
             <a:solidFill>
-              <a:srgbClr val="4A6FA5"/>
+              <a:srgbClr val="2E7DD1"/>
             </a:solidFill>
           </a:ln>
         </p:spPr>
@@ -5464,7 +5464,7 @@
             <a:avLst/>
           </a:prstGeom>
           <a:solidFill>
-            <a:srgbClr val="5E7EA8"/>
+            <a:srgbClr val="4A5FC1"/>
           </a:solidFill>
           <a:ln>
             <a:noFill/>
@@ -5583,7 +5583,7 @@
           </a:solidFill>
           <a:ln w="19050">
             <a:solidFill>
-              <a:srgbClr val="5E7EA8"/>
+              <a:srgbClr val="4A5FC1"/>
             </a:solidFill>
           </a:ln>
         </p:spPr>
@@ -5622,7 +5622,7 @@
             <a:r>
               <a:rPr sz="1100">
                 <a:solidFill>
-                  <a:srgbClr val="5E7EA8"/>
+                  <a:srgbClr val="4A5FC1"/>
                 </a:solidFill>
                 <a:latin typeface="Calibri"/>
               </a:rPr>
@@ -5647,7 +5647,7 @@
           </a:prstGeom>
           <a:ln w="25400">
             <a:solidFill>
-              <a:srgbClr val="5E7EA8"/>
+              <a:srgbClr val="4A5FC1"/>
             </a:solidFill>
             <a:tailEnd type="arrow" w="med" len="med"/>
           </a:ln>
@@ -5688,7 +5688,7 @@
           </a:solidFill>
           <a:ln w="19050">
             <a:solidFill>
-              <a:srgbClr val="5E7EA8"/>
+              <a:srgbClr val="4A5FC1"/>
             </a:solidFill>
           </a:ln>
         </p:spPr>
@@ -5727,7 +5727,7 @@
             <a:r>
               <a:rPr sz="1100">
                 <a:solidFill>
-                  <a:srgbClr val="5E7EA8"/>
+                  <a:srgbClr val="4A5FC1"/>
                 </a:solidFill>
                 <a:latin typeface="Calibri"/>
               </a:rPr>
@@ -5752,7 +5752,7 @@
           </a:prstGeom>
           <a:ln w="25400">
             <a:solidFill>
-              <a:srgbClr val="5E7EA8"/>
+              <a:srgbClr val="4A5FC1"/>
             </a:solidFill>
             <a:tailEnd type="arrow" w="med" len="med"/>
           </a:ln>
@@ -5793,7 +5793,7 @@
           </a:solidFill>
           <a:ln w="19050">
             <a:solidFill>
-              <a:srgbClr val="5E7EA8"/>
+              <a:srgbClr val="4A5FC1"/>
             </a:solidFill>
           </a:ln>
         </p:spPr>
@@ -5832,7 +5832,7 @@
             <a:r>
               <a:rPr sz="1100">
                 <a:solidFill>
-                  <a:srgbClr val="5E7EA8"/>
+                  <a:srgbClr val="4A5FC1"/>
                 </a:solidFill>
                 <a:latin typeface="Calibri"/>
               </a:rPr>
@@ -5857,7 +5857,7 @@
           </a:prstGeom>
           <a:ln w="25400">
             <a:solidFill>
-              <a:srgbClr val="5E7EA8"/>
+              <a:srgbClr val="4A5FC1"/>
             </a:solidFill>
             <a:tailEnd type="arrow" w="med" len="med"/>
           </a:ln>
@@ -5898,7 +5898,7 @@
           </a:solidFill>
           <a:ln w="19050">
             <a:solidFill>
-              <a:srgbClr val="5E7EA8"/>
+              <a:srgbClr val="4A5FC1"/>
             </a:solidFill>
           </a:ln>
         </p:spPr>
@@ -5937,7 +5937,7 @@
             <a:r>
               <a:rPr sz="1100">
                 <a:solidFill>
-                  <a:srgbClr val="5E7EA8"/>
+                  <a:srgbClr val="4A5FC1"/>
                 </a:solidFill>
                 <a:latin typeface="Calibri"/>
               </a:rPr>
@@ -5962,7 +5962,7 @@
           </a:prstGeom>
           <a:ln w="25400">
             <a:solidFill>
-              <a:srgbClr val="5E7EA8"/>
+              <a:srgbClr val="4A5FC1"/>
             </a:solidFill>
             <a:tailEnd type="arrow" w="med" len="med"/>
           </a:ln>
@@ -6003,7 +6003,7 @@
           </a:solidFill>
           <a:ln w="19050">
             <a:solidFill>
-              <a:srgbClr val="5E7EA8"/>
+              <a:srgbClr val="4A5FC1"/>
             </a:solidFill>
           </a:ln>
         </p:spPr>
@@ -6042,7 +6042,7 @@
             <a:r>
               <a:rPr sz="1100">
                 <a:solidFill>
-                  <a:srgbClr val="5E7EA8"/>
+                  <a:srgbClr val="4A5FC1"/>
                 </a:solidFill>
                 <a:latin typeface="Calibri"/>
               </a:rPr>
@@ -6318,7 +6318,7 @@
             <a:avLst/>
           </a:prstGeom>
           <a:solidFill>
-            <a:srgbClr val="5E7EA8"/>
+            <a:srgbClr val="4A5FC1"/>
           </a:solidFill>
           <a:ln>
             <a:noFill/>
@@ -6431,7 +6431,7 @@
             <a:avLst/>
           </a:prstGeom>
           <a:solidFill>
-            <a:srgbClr val="5E7EA8"/>
+            <a:srgbClr val="4A5FC1"/>
           </a:solidFill>
           <a:ln>
             <a:noFill/>
@@ -6489,10 +6489,10 @@
             <a:r>
               <a:rPr b="1" sz="2000">
                 <a:solidFill>
-                  <a:srgbClr val="5E7EA8"/>
-                </a:solidFill>
-              </a:rPr>
-              <a:t>▶ 職責：802.11 連線管理</a:t>
+                  <a:srgbClr val="4A5FC1"/>
+                </a:solidFill>
+              </a:rPr>
+              <a:t>▶ 職責：802.11 連線管理（Native 802.11 架構，Windows 10 起由 WDI 取代但概念相同）</a:t>
             </a:r>
           </a:p>
           <a:p>
@@ -6525,7 +6525,7 @@
             <a:r>
               <a:rPr b="1" sz="2000">
                 <a:solidFill>
-                  <a:srgbClr val="5E7EA8"/>
+                  <a:srgbClr val="4A5FC1"/>
                 </a:solidFill>
               </a:rPr>
               <a:t>▶ 向上暴露的介面：</a:t>
@@ -6576,7 +6576,7 @@
             <a:r>
               <a:rPr b="1" sz="2000">
                 <a:solidFill>
-                  <a:srgbClr val="5E7EA8"/>
+                  <a:srgbClr val="4A5FC1"/>
                 </a:solidFill>
               </a:rPr>
               <a:t>⚠ 不暴露任何 PHY 層原始資料</a:t>
@@ -6887,7 +6887,7 @@
             <a:avLst/>
           </a:prstGeom>
           <a:solidFill>
-            <a:srgbClr val="5E7EA8"/>
+            <a:srgbClr val="4A5FC1"/>
           </a:solidFill>
           <a:ln>
             <a:noFill/>
@@ -7000,7 +7000,7 @@
             <a:avLst/>
           </a:prstGeom>
           <a:solidFill>
-            <a:srgbClr val="5E7EA8"/>
+            <a:srgbClr val="4A5FC1"/>
           </a:solidFill>
           <a:ln>
             <a:noFill/>
@@ -7130,7 +7130,7 @@
             <a:r>
               <a:rPr b="1" sz="2000">
                 <a:solidFill>
-                  <a:srgbClr val="5E7EA8"/>
+                  <a:srgbClr val="4A5FC1"/>
                 </a:solidFill>
               </a:rPr>
               <a:t>▶ 為什麼無法標準化 CSI？</a:t>
@@ -7471,7 +7471,7 @@
             <a:avLst/>
           </a:prstGeom>
           <a:solidFill>
-            <a:srgbClr val="5E7EA8"/>
+            <a:srgbClr val="4A5FC1"/>
           </a:solidFill>
           <a:ln>
             <a:noFill/>
@@ -7630,7 +7630,7 @@
             <a:r>
               <a:rPr sz="1800" b="1">
                 <a:solidFill>
-                  <a:srgbClr val="5E7EA8"/>
+                  <a:srgbClr val="4A5FC1"/>
                 </a:solidFill>
                 <a:latin typeface="Calibri"/>
               </a:rPr>
@@ -7793,7 +7793,7 @@
             <a:r>
               <a:rPr sz="1800" b="1">
                 <a:solidFill>
-                  <a:srgbClr val="4A6FA5"/>
+                  <a:srgbClr val="2E7DD1"/>
                 </a:solidFill>
                 <a:latin typeface="Calibri"/>
               </a:rPr>
@@ -8224,7 +8224,7 @@
             <a:avLst/>
           </a:prstGeom>
           <a:solidFill>
-            <a:srgbClr val="5E7EA8"/>
+            <a:srgbClr val="4A5FC1"/>
           </a:solidFill>
           <a:ln>
             <a:noFill/>
@@ -8337,11 +8337,11 @@
             <a:avLst/>
           </a:prstGeom>
           <a:solidFill>
-            <a:srgbClr val="33455C"/>
+            <a:srgbClr val="28346A"/>
           </a:solidFill>
           <a:ln w="12700">
             <a:solidFill>
-              <a:srgbClr val="5E7EA8"/>
+              <a:srgbClr val="4A5FC1"/>
             </a:solidFill>
           </a:ln>
         </p:spPr>
@@ -8426,11 +8426,11 @@
             <a:avLst/>
           </a:prstGeom>
           <a:solidFill>
-            <a:srgbClr val="33455C"/>
+            <a:srgbClr val="28346A"/>
           </a:solidFill>
           <a:ln w="12700">
             <a:solidFill>
-              <a:srgbClr val="5E7EA8"/>
+              <a:srgbClr val="4A5FC1"/>
             </a:solidFill>
           </a:ln>
         </p:spPr>
@@ -8786,7 +8786,7 @@
           </a:solidFill>
           <a:ln w="12700">
             <a:solidFill>
-              <a:srgbClr val="4A8F8F"/>
+              <a:srgbClr val="0E8F8F"/>
             </a:solidFill>
           </a:ln>
         </p:spPr>
@@ -8847,7 +8847,7 @@
             <a:r>
               <a:rPr sz="1300" b="0">
                 <a:solidFill>
-                  <a:srgbClr val="4A8F8F"/>
+                  <a:srgbClr val="0E8F8F"/>
                 </a:solidFill>
                 <a:latin typeface="Calibri"/>
               </a:rPr>
@@ -9080,7 +9080,7 @@
             <a:avLst/>
           </a:prstGeom>
           <a:solidFill>
-            <a:srgbClr val="4A8F8F"/>
+            <a:srgbClr val="0E8F8F"/>
           </a:solidFill>
           <a:ln>
             <a:noFill/>
@@ -9134,7 +9134,7 @@
             <a:r>
               <a:rPr sz="16000" b="1">
                 <a:solidFill>
-                  <a:srgbClr val="33474D"/>
+                  <a:srgbClr val="24474D"/>
                 </a:solidFill>
                 <a:latin typeface="Calibri"/>
               </a:rPr>
@@ -9204,7 +9204,7 @@
             <a:r>
               <a:rPr sz="2200" b="0">
                 <a:solidFill>
-                  <a:srgbClr val="4A8F8F"/>
+                  <a:srgbClr val="0E8F8F"/>
                 </a:solidFill>
                 <a:latin typeface="Calibri"/>
               </a:rPr>
@@ -9229,7 +9229,7 @@
           </a:prstGeom>
           <a:ln w="19050">
             <a:solidFill>
-              <a:srgbClr val="4A8F8F"/>
+              <a:srgbClr val="0E8F8F"/>
             </a:solidFill>
           </a:ln>
         </p:spPr>
@@ -9445,7 +9445,7 @@
             <a:avLst/>
           </a:prstGeom>
           <a:solidFill>
-            <a:srgbClr val="4A8F8F"/>
+            <a:srgbClr val="0E8F8F"/>
           </a:solidFill>
           <a:ln>
             <a:noFill/>
@@ -9604,7 +9604,7 @@
             <a:r>
               <a:rPr sz="1800" b="1">
                 <a:solidFill>
-                  <a:srgbClr val="4A8F8F"/>
+                  <a:srgbClr val="0E8F8F"/>
                 </a:solidFill>
                 <a:latin typeface="Calibri"/>
               </a:rPr>
@@ -9824,7 +9824,7 @@
             <a:r>
               <a:rPr sz="1800" b="1">
                 <a:solidFill>
-                  <a:srgbClr val="4A6FA5"/>
+                  <a:srgbClr val="2E7DD1"/>
                 </a:solidFill>
                 <a:latin typeface="Calibri"/>
               </a:rPr>
@@ -10234,7 +10234,7 @@
             <a:avLst/>
           </a:prstGeom>
           <a:solidFill>
-            <a:srgbClr val="4A8F8F"/>
+            <a:srgbClr val="0E8F8F"/>
           </a:solidFill>
           <a:ln>
             <a:noFill/>
@@ -10483,7 +10483,7 @@
                       <a:r>
                         <a:rPr sz="1400" b="1">
                           <a:solidFill>
-                            <a:srgbClr val="4A8F8F"/>
+                            <a:srgbClr val="0E8F8F"/>
                           </a:solidFill>
                           <a:latin typeface="Calibri"/>
                         </a:rPr>
@@ -10595,7 +10595,7 @@
                       <a:r>
                         <a:rPr sz="1400" b="1">
                           <a:solidFill>
-                            <a:srgbClr val="4A8F8F"/>
+                            <a:srgbClr val="0E8F8F"/>
                           </a:solidFill>
                           <a:latin typeface="Calibri"/>
                         </a:rPr>
@@ -10707,7 +10707,7 @@
                       <a:r>
                         <a:rPr sz="1400" b="1">
                           <a:solidFill>
-                            <a:srgbClr val="4A8F8F"/>
+                            <a:srgbClr val="0E8F8F"/>
                           </a:solidFill>
                           <a:latin typeface="Calibri"/>
                         </a:rPr>
@@ -10819,7 +10819,7 @@
                       <a:r>
                         <a:rPr sz="1400" b="1">
                           <a:solidFill>
-                            <a:srgbClr val="4A8F8F"/>
+                            <a:srgbClr val="0E8F8F"/>
                           </a:solidFill>
                           <a:latin typeface="Calibri"/>
                         </a:rPr>
@@ -10931,7 +10931,7 @@
                       <a:r>
                         <a:rPr sz="1400" b="1">
                           <a:solidFill>
-                            <a:srgbClr val="4A8F8F"/>
+                            <a:srgbClr val="0E8F8F"/>
                           </a:solidFill>
                           <a:latin typeface="Calibri"/>
                         </a:rPr>
@@ -11043,7 +11043,7 @@
                       <a:r>
                         <a:rPr sz="1400" b="1">
                           <a:solidFill>
-                            <a:srgbClr val="4A8F8F"/>
+                            <a:srgbClr val="0E8F8F"/>
                           </a:solidFill>
                           <a:latin typeface="Calibri"/>
                         </a:rPr>
@@ -11417,7 +11417,7 @@
             <a:avLst/>
           </a:prstGeom>
           <a:solidFill>
-            <a:srgbClr val="4A8F8F"/>
+            <a:srgbClr val="0E8F8F"/>
           </a:solidFill>
           <a:ln>
             <a:noFill/>
@@ -11666,7 +11666,7 @@
                       <a:r>
                         <a:rPr sz="1400" b="1">
                           <a:solidFill>
-                            <a:srgbClr val="4A8F8F"/>
+                            <a:srgbClr val="0E8F8F"/>
                           </a:solidFill>
                           <a:latin typeface="Calibri"/>
                         </a:rPr>
@@ -11783,7 +11783,7 @@
                       <a:r>
                         <a:rPr sz="1400" b="1">
                           <a:solidFill>
-                            <a:srgbClr val="4A8F8F"/>
+                            <a:srgbClr val="0E8F8F"/>
                           </a:solidFill>
                           <a:latin typeface="Calibri"/>
                         </a:rPr>
@@ -11900,7 +11900,7 @@
                       <a:r>
                         <a:rPr sz="1400" b="1">
                           <a:solidFill>
-                            <a:srgbClr val="4A8F8F"/>
+                            <a:srgbClr val="0E8F8F"/>
                           </a:solidFill>
                           <a:latin typeface="Calibri"/>
                         </a:rPr>
@@ -12012,7 +12012,7 @@
                       <a:r>
                         <a:rPr sz="1400" b="1">
                           <a:solidFill>
-                            <a:srgbClr val="4A8F8F"/>
+                            <a:srgbClr val="0E8F8F"/>
                           </a:solidFill>
                           <a:latin typeface="Calibri"/>
                         </a:rPr>
@@ -12391,7 +12391,7 @@
             <a:avLst/>
           </a:prstGeom>
           <a:solidFill>
-            <a:srgbClr val="4A8F8F"/>
+            <a:srgbClr val="0E8F8F"/>
           </a:solidFill>
           <a:ln>
             <a:noFill/>
@@ -12640,7 +12640,7 @@
                       <a:r>
                         <a:rPr sz="1400" b="1">
                           <a:solidFill>
-                            <a:srgbClr val="4A8F8F"/>
+                            <a:srgbClr val="0E8F8F"/>
                           </a:solidFill>
                           <a:latin typeface="Calibri"/>
                         </a:rPr>
@@ -12752,7 +12752,7 @@
                       <a:r>
                         <a:rPr sz="1400" b="1">
                           <a:solidFill>
-                            <a:srgbClr val="4A8F8F"/>
+                            <a:srgbClr val="0E8F8F"/>
                           </a:solidFill>
                           <a:latin typeface="Calibri"/>
                         </a:rPr>
@@ -12864,7 +12864,7 @@
                       <a:r>
                         <a:rPr sz="1400" b="1">
                           <a:solidFill>
-                            <a:srgbClr val="4A8F8F"/>
+                            <a:srgbClr val="0E8F8F"/>
                           </a:solidFill>
                           <a:latin typeface="Calibri"/>
                         </a:rPr>
@@ -12976,7 +12976,7 @@
                       <a:r>
                         <a:rPr sz="1400" b="1">
                           <a:solidFill>
-                            <a:srgbClr val="4A8F8F"/>
+                            <a:srgbClr val="0E8F8F"/>
                           </a:solidFill>
                           <a:latin typeface="Calibri"/>
                         </a:rPr>
@@ -13088,7 +13088,7 @@
                       <a:r>
                         <a:rPr sz="1400" b="1">
                           <a:solidFill>
-                            <a:srgbClr val="4A8F8F"/>
+                            <a:srgbClr val="0E8F8F"/>
                           </a:solidFill>
                           <a:latin typeface="Calibri"/>
                         </a:rPr>
@@ -13200,7 +13200,7 @@
                       <a:r>
                         <a:rPr sz="1400" b="1">
                           <a:solidFill>
-                            <a:srgbClr val="4A8F8F"/>
+                            <a:srgbClr val="0E8F8F"/>
                           </a:solidFill>
                           <a:latin typeface="Calibri"/>
                         </a:rPr>
@@ -13226,7 +13226,7 @@
                           </a:solidFill>
                           <a:latin typeface="Calibri"/>
                         </a:rPr>
-                        <a:t>BCM43455</a:t>
+                        <a:t>CYW43455 (原BCM43455)</a:t>
                       </a:r>
                     </a:p>
                   </a:txBody>
@@ -13574,7 +13574,7 @@
             <a:avLst/>
           </a:prstGeom>
           <a:solidFill>
-            <a:srgbClr val="4A6FA5"/>
+            <a:srgbClr val="2E7DD1"/>
           </a:solidFill>
           <a:ln>
             <a:noFill/>
@@ -13652,7 +13652,7 @@
             <a:avLst/>
           </a:prstGeom>
           <a:solidFill>
-            <a:srgbClr val="4A6FA5"/>
+            <a:srgbClr val="2E7DD1"/>
           </a:solidFill>
           <a:ln>
             <a:noFill/>
@@ -13987,7 +13987,7 @@
             <a:avLst/>
           </a:prstGeom>
           <a:solidFill>
-            <a:srgbClr val="B87040"/>
+            <a:srgbClr val="C0602A"/>
           </a:solidFill>
           <a:ln>
             <a:noFill/>
@@ -14041,7 +14041,7 @@
             <a:r>
               <a:rPr sz="16000" b="1">
                 <a:solidFill>
-                  <a:srgbClr val="4F403A"/>
+                  <a:srgbClr val="513C34"/>
                 </a:solidFill>
                 <a:latin typeface="Calibri"/>
               </a:rPr>
@@ -14111,7 +14111,7 @@
             <a:r>
               <a:rPr sz="2200" b="0">
                 <a:solidFill>
-                  <a:srgbClr val="B87040"/>
+                  <a:srgbClr val="C0602A"/>
                 </a:solidFill>
                 <a:latin typeface="Calibri"/>
               </a:rPr>
@@ -14136,7 +14136,7 @@
           </a:prstGeom>
           <a:ln w="19050">
             <a:solidFill>
-              <a:srgbClr val="B87040"/>
+              <a:srgbClr val="C0602A"/>
             </a:solidFill>
           </a:ln>
         </p:spPr>
@@ -14352,7 +14352,7 @@
             <a:avLst/>
           </a:prstGeom>
           <a:solidFill>
-            <a:srgbClr val="B87040"/>
+            <a:srgbClr val="C0602A"/>
           </a:solidFill>
           <a:ln>
             <a:noFill/>
@@ -14465,11 +14465,11 @@
             <a:avLst/>
           </a:prstGeom>
           <a:solidFill>
-            <a:srgbClr val="653D23"/>
+            <a:srgbClr val="693417"/>
           </a:solidFill>
           <a:ln w="12700">
             <a:solidFill>
-              <a:srgbClr val="B87040"/>
+              <a:srgbClr val="C0602A"/>
             </a:solidFill>
           </a:ln>
         </p:spPr>
@@ -14825,7 +14825,7 @@
           </a:solidFill>
           <a:ln w="12700">
             <a:solidFill>
-              <a:srgbClr val="4A8F8F"/>
+              <a:srgbClr val="0E8F8F"/>
             </a:solidFill>
           </a:ln>
         </p:spPr>
@@ -14886,7 +14886,7 @@
             <a:r>
               <a:rPr sz="1300" b="0">
                 <a:solidFill>
-                  <a:srgbClr val="4A8F8F"/>
+                  <a:srgbClr val="0E8F8F"/>
                 </a:solidFill>
                 <a:latin typeface="Calibri"/>
               </a:rPr>
@@ -14914,7 +14914,7 @@
           </a:solidFill>
           <a:ln w="12700">
             <a:solidFill>
-              <a:srgbClr val="4A8F8F"/>
+              <a:srgbClr val="0E8F8F"/>
             </a:solidFill>
           </a:ln>
         </p:spPr>
@@ -14975,7 +14975,7 @@
             <a:r>
               <a:rPr sz="1300" b="0">
                 <a:solidFill>
-                  <a:srgbClr val="4A8F8F"/>
+                  <a:srgbClr val="0E8F8F"/>
                 </a:solidFill>
                 <a:latin typeface="Calibri"/>
               </a:rPr>
@@ -15251,7 +15251,7 @@
             <a:avLst/>
           </a:prstGeom>
           <a:solidFill>
-            <a:srgbClr val="B87040"/>
+            <a:srgbClr val="C0602A"/>
           </a:solidFill>
           <a:ln>
             <a:noFill/>
@@ -15364,7 +15364,7 @@
             <a:avLst/>
           </a:prstGeom>
           <a:solidFill>
-            <a:srgbClr val="B87040"/>
+            <a:srgbClr val="C0602A"/>
           </a:solidFill>
           <a:ln>
             <a:noFill/>
@@ -15422,7 +15422,7 @@
             <a:r>
               <a:rPr b="1" sz="2000">
                 <a:solidFill>
-                  <a:srgbClr val="B87040"/>
+                  <a:srgbClr val="C0602A"/>
                 </a:solidFill>
               </a:rPr>
               <a:t>1. 選硬體先確認 CSI 工具支援</a:t>
@@ -15458,7 +15458,7 @@
             <a:r>
               <a:rPr b="1" sz="2000">
                 <a:solidFill>
-                  <a:srgbClr val="B87040"/>
+                  <a:srgbClr val="C0602A"/>
                 </a:solidFill>
               </a:rPr>
               <a:t>2. 優先 Linux 環境採集 CSI</a:t>
@@ -15509,7 +15509,7 @@
             <a:r>
               <a:rPr b="1" sz="2000">
                 <a:solidFill>
-                  <a:srgbClr val="B87040"/>
+                  <a:srgbClr val="C0602A"/>
                 </a:solidFill>
               </a:rPr>
               <a:t>3. 避免的坑</a:t>
@@ -15759,7 +15759,7 @@
             <a:avLst/>
           </a:prstGeom>
           <a:solidFill>
-            <a:srgbClr val="B87040"/>
+            <a:srgbClr val="C0602A"/>
           </a:solidFill>
           <a:ln>
             <a:noFill/>
@@ -15887,11 +15887,11 @@
             <a:r>
               <a:rPr sz="1400">
                 <a:solidFill>
-                  <a:srgbClr val="4A6FA5"/>
+                  <a:srgbClr val="2E7DD1"/>
                 </a:solidFill>
                 <a:latin typeface="Calibri"/>
               </a:rPr>
-              <a:t>[1] D. Halperin et al., Tool Release: Gathering 802.11n Traces with CSI, ACM SIGCOMM, 2011. -&gt; linux-80211n-csitool</a:t>
+              <a:t>[1] D. Halperin et al., Tool Release: Gathering 802.11n Traces with CSI, ACM SIGCOMM CCR, Vol. 41, No. 1, 2011. -&gt; linux-80211n-csitool</a:t>
             </a:r>
           </a:p>
           <a:p>
@@ -15903,7 +15903,7 @@
             <a:r>
               <a:rPr sz="1400">
                 <a:solidFill>
-                  <a:srgbClr val="4A6FA5"/>
+                  <a:srgbClr val="2E7DD1"/>
                 </a:solidFill>
                 <a:latin typeface="Calibri"/>
               </a:rPr>
@@ -15919,7 +15919,7 @@
             <a:r>
               <a:rPr sz="1400">
                 <a:solidFill>
-                  <a:srgbClr val="4A6FA5"/>
+                  <a:srgbClr val="2E7DD1"/>
                 </a:solidFill>
                 <a:latin typeface="Calibri"/>
               </a:rPr>
@@ -15935,7 +15935,7 @@
             <a:r>
               <a:rPr sz="1400">
                 <a:solidFill>
-                  <a:srgbClr val="4A6FA5"/>
+                  <a:srgbClr val="2E7DD1"/>
                 </a:solidFill>
                 <a:latin typeface="Calibri"/>
               </a:rPr>
@@ -15951,11 +15951,11 @@
             <a:r>
               <a:rPr sz="1400">
                 <a:solidFill>
-                  <a:srgbClr val="4A6FA5"/>
+                  <a:srgbClr val="2E7DD1"/>
                 </a:solidFill>
                 <a:latin typeface="Calibri"/>
               </a:rPr>
-              <a:t>[5] X. Yaxiong et al., Atheros CSI Tool for 802.11n NICs -- xieyaxiongfly/Atheros-CSI-Tool</a:t>
+              <a:t>[5] Y. Xie et al., Atheros CSI Tool for 802.11n NICs -- xieyaxiongfly/Atheros-CSI-Tool</a:t>
             </a:r>
           </a:p>
           <a:p>
@@ -15967,7 +15967,7 @@
             <a:r>
               <a:rPr sz="1400">
                 <a:solidFill>
-                  <a:srgbClr val="4A6FA5"/>
+                  <a:srgbClr val="2E7DD1"/>
                 </a:solidFill>
                 <a:latin typeface="Calibri"/>
               </a:rPr>
@@ -15983,7 +15983,7 @@
             <a:r>
               <a:rPr sz="1400">
                 <a:solidFill>
-                  <a:srgbClr val="4A6FA5"/>
+                  <a:srgbClr val="2E7DD1"/>
                 </a:solidFill>
                 <a:latin typeface="Calibri"/>
               </a:rPr>
@@ -15999,7 +15999,7 @@
             <a:r>
               <a:rPr sz="1400">
                 <a:solidFill>
-                  <a:srgbClr val="4A6FA5"/>
+                  <a:srgbClr val="2E7DD1"/>
                 </a:solidFill>
                 <a:latin typeface="Calibri"/>
               </a:rPr>
@@ -16162,7 +16162,7 @@
             <a:avLst/>
           </a:prstGeom>
           <a:solidFill>
-            <a:srgbClr val="4A6FA5"/>
+            <a:srgbClr val="2E7DD1"/>
           </a:solidFill>
           <a:ln>
             <a:noFill/>
@@ -16216,7 +16216,7 @@
             <a:r>
               <a:rPr sz="16000" b="1">
                 <a:solidFill>
-                  <a:srgbClr val="333F53"/>
+                  <a:srgbClr val="2C435E"/>
                 </a:solidFill>
                 <a:latin typeface="Calibri"/>
               </a:rPr>
@@ -16286,7 +16286,7 @@
             <a:r>
               <a:rPr sz="2200" b="0">
                 <a:solidFill>
-                  <a:srgbClr val="4A6FA5"/>
+                  <a:srgbClr val="2E7DD1"/>
                 </a:solidFill>
                 <a:latin typeface="Calibri"/>
               </a:rPr>
@@ -16311,7 +16311,7 @@
           </a:prstGeom>
           <a:ln w="19050">
             <a:solidFill>
-              <a:srgbClr val="4A6FA5"/>
+              <a:srgbClr val="2E7DD1"/>
             </a:solidFill>
           </a:ln>
         </p:spPr>
@@ -16527,7 +16527,7 @@
             <a:avLst/>
           </a:prstGeom>
           <a:solidFill>
-            <a:srgbClr val="4A6FA5"/>
+            <a:srgbClr val="2E7DD1"/>
           </a:solidFill>
           <a:ln>
             <a:noFill/>
@@ -16646,7 +16646,7 @@
           </a:solidFill>
           <a:ln w="19050">
             <a:solidFill>
-              <a:srgbClr val="4A6FA5"/>
+              <a:srgbClr val="2E7DD1"/>
             </a:solidFill>
           </a:ln>
         </p:spPr>
@@ -16685,7 +16685,7 @@
             <a:r>
               <a:rPr sz="1100">
                 <a:solidFill>
-                  <a:srgbClr val="4A6FA5"/>
+                  <a:srgbClr val="2E7DD1"/>
                 </a:solidFill>
                 <a:latin typeface="Calibri"/>
               </a:rPr>
@@ -16710,7 +16710,7 @@
           </a:prstGeom>
           <a:ln w="25400">
             <a:solidFill>
-              <a:srgbClr val="4A6FA5"/>
+              <a:srgbClr val="2E7DD1"/>
             </a:solidFill>
             <a:tailEnd type="arrow" w="med" len="med"/>
           </a:ln>
@@ -16751,7 +16751,7 @@
           </a:solidFill>
           <a:ln w="19050">
             <a:solidFill>
-              <a:srgbClr val="4A6FA5"/>
+              <a:srgbClr val="2E7DD1"/>
             </a:solidFill>
           </a:ln>
         </p:spPr>
@@ -16790,7 +16790,7 @@
             <a:r>
               <a:rPr sz="1100">
                 <a:solidFill>
-                  <a:srgbClr val="4A6FA5"/>
+                  <a:srgbClr val="2E7DD1"/>
                 </a:solidFill>
                 <a:latin typeface="Calibri"/>
               </a:rPr>
@@ -16815,7 +16815,7 @@
           </a:prstGeom>
           <a:ln w="25400">
             <a:solidFill>
-              <a:srgbClr val="4A6FA5"/>
+              <a:srgbClr val="2E7DD1"/>
             </a:solidFill>
             <a:tailEnd type="arrow" w="med" len="med"/>
           </a:ln>
@@ -16856,7 +16856,7 @@
           </a:solidFill>
           <a:ln w="19050">
             <a:solidFill>
-              <a:srgbClr val="4A6FA5"/>
+              <a:srgbClr val="2E7DD1"/>
             </a:solidFill>
           </a:ln>
         </p:spPr>
@@ -16895,7 +16895,7 @@
             <a:r>
               <a:rPr sz="1100">
                 <a:solidFill>
-                  <a:srgbClr val="4A6FA5"/>
+                  <a:srgbClr val="2E7DD1"/>
                 </a:solidFill>
                 <a:latin typeface="Calibri"/>
               </a:rPr>
@@ -16920,7 +16920,7 @@
           </a:prstGeom>
           <a:ln w="25400">
             <a:solidFill>
-              <a:srgbClr val="4A6FA5"/>
+              <a:srgbClr val="2E7DD1"/>
             </a:solidFill>
             <a:tailEnd type="arrow" w="med" len="med"/>
           </a:ln>
@@ -16961,7 +16961,7 @@
           </a:solidFill>
           <a:ln w="19050">
             <a:solidFill>
-              <a:srgbClr val="4A6FA5"/>
+              <a:srgbClr val="2E7DD1"/>
             </a:solidFill>
           </a:ln>
         </p:spPr>
@@ -17000,7 +17000,7 @@
             <a:r>
               <a:rPr sz="1100">
                 <a:solidFill>
-                  <a:srgbClr val="4A6FA5"/>
+                  <a:srgbClr val="2E7DD1"/>
                 </a:solidFill>
                 <a:latin typeface="Calibri"/>
               </a:rPr>
@@ -17025,7 +17025,7 @@
           </a:prstGeom>
           <a:ln w="25400">
             <a:solidFill>
-              <a:srgbClr val="4A6FA5"/>
+              <a:srgbClr val="2E7DD1"/>
             </a:solidFill>
             <a:tailEnd type="arrow" w="med" len="med"/>
           </a:ln>
@@ -17066,7 +17066,7 @@
           </a:solidFill>
           <a:ln w="19050">
             <a:solidFill>
-              <a:srgbClr val="4A6FA5"/>
+              <a:srgbClr val="2E7DD1"/>
             </a:solidFill>
           </a:ln>
         </p:spPr>
@@ -17105,7 +17105,7 @@
             <a:r>
               <a:rPr sz="1100">
                 <a:solidFill>
-                  <a:srgbClr val="4A6FA5"/>
+                  <a:srgbClr val="2E7DD1"/>
                 </a:solidFill>
                 <a:latin typeface="Calibri"/>
               </a:rPr>
@@ -17381,7 +17381,7 @@
             <a:avLst/>
           </a:prstGeom>
           <a:solidFill>
-            <a:srgbClr val="4A6FA5"/>
+            <a:srgbClr val="2E7DD1"/>
           </a:solidFill>
           <a:ln>
             <a:noFill/>
@@ -17540,7 +17540,7 @@
             <a:r>
               <a:rPr sz="1800" b="1">
                 <a:solidFill>
-                  <a:srgbClr val="4A6FA5"/>
+                  <a:srgbClr val="2E7DD1"/>
                 </a:solidFill>
                 <a:latin typeface="Calibri"/>
               </a:rPr>
@@ -17658,7 +17658,7 @@
             <a:r>
               <a:rPr sz="1800" b="1">
                 <a:solidFill>
-                  <a:srgbClr val="4A6FA5"/>
+                  <a:srgbClr val="2E7DD1"/>
                 </a:solidFill>
                 <a:latin typeface="Calibri"/>
               </a:rPr>
@@ -18059,7 +18059,7 @@
             <a:avLst/>
           </a:prstGeom>
           <a:solidFill>
-            <a:srgbClr val="4A6FA5"/>
+            <a:srgbClr val="2E7DD1"/>
           </a:solidFill>
           <a:ln>
             <a:noFill/>
@@ -18284,7 +18284,7 @@
                       <a:r>
                         <a:rPr sz="1400" b="1">
                           <a:solidFill>
-                            <a:srgbClr val="4A6FA5"/>
+                            <a:srgbClr val="2E7DD1"/>
                           </a:solidFill>
                           <a:latin typeface="Calibri"/>
                         </a:rPr>
@@ -18374,7 +18374,7 @@
                       <a:r>
                         <a:rPr sz="1400" b="1">
                           <a:solidFill>
-                            <a:srgbClr val="4A6FA5"/>
+                            <a:srgbClr val="2E7DD1"/>
                           </a:solidFill>
                           <a:latin typeface="Calibri"/>
                         </a:rPr>
@@ -18464,7 +18464,7 @@
                       <a:r>
                         <a:rPr sz="1400" b="1">
                           <a:solidFill>
-                            <a:srgbClr val="4A6FA5"/>
+                            <a:srgbClr val="2E7DD1"/>
                           </a:solidFill>
                           <a:latin typeface="Calibri"/>
                         </a:rPr>
@@ -18554,7 +18554,7 @@
                       <a:r>
                         <a:rPr sz="1400" b="1">
                           <a:solidFill>
-                            <a:srgbClr val="4A6FA5"/>
+                            <a:srgbClr val="2E7DD1"/>
                           </a:solidFill>
                           <a:latin typeface="Calibri"/>
                         </a:rPr>
@@ -18644,7 +18644,7 @@
                       <a:r>
                         <a:rPr sz="1400" b="1">
                           <a:solidFill>
-                            <a:srgbClr val="4A6FA5"/>
+                            <a:srgbClr val="2E7DD1"/>
                           </a:solidFill>
                           <a:latin typeface="Calibri"/>
                         </a:rPr>
@@ -18734,7 +18734,7 @@
                       <a:r>
                         <a:rPr sz="1400" b="1">
                           <a:solidFill>
-                            <a:srgbClr val="4A6FA5"/>
+                            <a:srgbClr val="2E7DD1"/>
                           </a:solidFill>
                           <a:latin typeface="Calibri"/>
                         </a:rPr>
@@ -19043,7 +19043,7 @@
             <a:avLst/>
           </a:prstGeom>
           <a:solidFill>
-            <a:srgbClr val="5E7EA8"/>
+            <a:srgbClr val="4A5FC1"/>
           </a:solidFill>
           <a:ln>
             <a:noFill/>
@@ -19097,7 +19097,7 @@
             <a:r>
               <a:rPr sz="16000" b="1">
                 <a:solidFill>
-                  <a:srgbClr val="384354"/>
+                  <a:srgbClr val="333B5A"/>
                 </a:solidFill>
                 <a:latin typeface="Calibri"/>
               </a:rPr>
@@ -19167,7 +19167,7 @@
             <a:r>
               <a:rPr sz="2200" b="0">
                 <a:solidFill>
-                  <a:srgbClr val="5E7EA8"/>
+                  <a:srgbClr val="4A5FC1"/>
                 </a:solidFill>
                 <a:latin typeface="Calibri"/>
               </a:rPr>
@@ -19192,7 +19192,7 @@
           </a:prstGeom>
           <a:ln w="19050">
             <a:solidFill>
-              <a:srgbClr val="5E7EA8"/>
+              <a:srgbClr val="4A5FC1"/>
             </a:solidFill>
           </a:ln>
         </p:spPr>
@@ -19408,7 +19408,7 @@
             <a:avLst/>
           </a:prstGeom>
           <a:solidFill>
-            <a:srgbClr val="5E7EA8"/>
+            <a:srgbClr val="4A5FC1"/>
           </a:solidFill>
           <a:ln>
             <a:noFill/>
@@ -19521,11 +19521,11 @@
             <a:avLst/>
           </a:prstGeom>
           <a:solidFill>
-            <a:srgbClr val="202C3A"/>
+            <a:srgbClr val="192143"/>
           </a:solidFill>
           <a:ln w="12700">
             <a:solidFill>
-              <a:srgbClr val="5E7EA8"/>
+              <a:srgbClr val="4A5FC1"/>
             </a:solidFill>
           </a:ln>
         </p:spPr>
@@ -19611,7 +19611,7 @@
           </a:prstGeom>
           <a:ln w="12700">
             <a:solidFill>
-              <a:srgbClr val="5E7EA8"/>
+              <a:srgbClr val="4A5FC1"/>
             </a:solidFill>
           </a:ln>
         </p:spPr>
@@ -19645,11 +19645,11 @@
             <a:avLst/>
           </a:prstGeom>
           <a:solidFill>
-            <a:srgbClr val="283648"/>
+            <a:srgbClr val="1F2852"/>
           </a:solidFill>
           <a:ln w="12700">
             <a:solidFill>
-              <a:srgbClr val="5E7EA8"/>
+              <a:srgbClr val="4A5FC1"/>
             </a:solidFill>
           </a:ln>
         </p:spPr>
@@ -19735,7 +19735,7 @@
           </a:prstGeom>
           <a:ln w="12700">
             <a:solidFill>
-              <a:srgbClr val="5E7EA8"/>
+              <a:srgbClr val="4A5FC1"/>
             </a:solidFill>
           </a:ln>
         </p:spPr>
@@ -19769,11 +19769,11 @@
             <a:avLst/>
           </a:prstGeom>
           <a:solidFill>
-            <a:srgbClr val="2F3F55"/>
+            <a:srgbClr val="253061"/>
           </a:solidFill>
           <a:ln w="12700">
             <a:solidFill>
-              <a:srgbClr val="5E7EA8"/>
+              <a:srgbClr val="4A5FC1"/>
             </a:solidFill>
           </a:ln>
         </p:spPr>
@@ -19859,7 +19859,7 @@
           </a:prstGeom>
           <a:ln w="12700">
             <a:solidFill>
-              <a:srgbClr val="5E7EA8"/>
+              <a:srgbClr val="4A5FC1"/>
             </a:solidFill>
           </a:ln>
         </p:spPr>
@@ -19893,11 +19893,11 @@
             <a:avLst/>
           </a:prstGeom>
           <a:solidFill>
-            <a:srgbClr val="374962"/>
+            <a:srgbClr val="2B3771"/>
           </a:solidFill>
           <a:ln w="12700">
             <a:solidFill>
-              <a:srgbClr val="5E7EA8"/>
+              <a:srgbClr val="4A5FC1"/>
             </a:solidFill>
           </a:ln>
         </p:spPr>
@@ -19983,7 +19983,7 @@
           </a:prstGeom>
           <a:ln w="12700">
             <a:solidFill>
-              <a:srgbClr val="5E7EA8"/>
+              <a:srgbClr val="4A5FC1"/>
             </a:solidFill>
           </a:ln>
         </p:spPr>
@@ -20017,11 +20017,11 @@
             <a:avLst/>
           </a:prstGeom>
           <a:solidFill>
-            <a:srgbClr val="3E536F"/>
+            <a:srgbClr val="313F80"/>
           </a:solidFill>
           <a:ln w="12700">
             <a:solidFill>
-              <a:srgbClr val="5E7EA8"/>
+              <a:srgbClr val="4A5FC1"/>
             </a:solidFill>
           </a:ln>
         </p:spPr>
@@ -20107,7 +20107,7 @@
           </a:prstGeom>
           <a:ln w="12700">
             <a:solidFill>
-              <a:srgbClr val="5E7EA8"/>
+              <a:srgbClr val="4A5FC1"/>
             </a:solidFill>
           </a:ln>
         </p:spPr>
@@ -20141,11 +20141,11 @@
             <a:avLst/>
           </a:prstGeom>
           <a:solidFill>
-            <a:srgbClr val="455D7C"/>
+            <a:srgbClr val="36468F"/>
           </a:solidFill>
           <a:ln w="12700">
             <a:solidFill>
-              <a:srgbClr val="5E7EA8"/>
+              <a:srgbClr val="4A5FC1"/>
             </a:solidFill>
           </a:ln>
         </p:spPr>
@@ -20231,7 +20231,7 @@
           </a:prstGeom>
           <a:ln w="12700">
             <a:solidFill>
-              <a:srgbClr val="5E7EA8"/>
+              <a:srgbClr val="4A5FC1"/>
             </a:solidFill>
           </a:ln>
         </p:spPr>
@@ -20265,11 +20265,11 @@
             <a:avLst/>
           </a:prstGeom>
           <a:solidFill>
-            <a:srgbClr val="4D678A"/>
+            <a:srgbClr val="3C4E9E"/>
           </a:solidFill>
           <a:ln w="12700">
             <a:solidFill>
-              <a:srgbClr val="5E7EA8"/>
+              <a:srgbClr val="4A5FC1"/>
             </a:solidFill>
           </a:ln>
         </p:spPr>
@@ -20355,7 +20355,7 @@
           </a:prstGeom>
           <a:ln w="12700">
             <a:solidFill>
-              <a:srgbClr val="5E7EA8"/>
+              <a:srgbClr val="4A5FC1"/>
             </a:solidFill>
           </a:ln>
         </p:spPr>
@@ -20389,11 +20389,11 @@
             <a:avLst/>
           </a:prstGeom>
           <a:solidFill>
-            <a:srgbClr val="547197"/>
+            <a:srgbClr val="4255AD"/>
           </a:solidFill>
           <a:ln w="12700">
             <a:solidFill>
-              <a:srgbClr val="5E7EA8"/>
+              <a:srgbClr val="4A5FC1"/>
             </a:solidFill>
           </a:ln>
         </p:spPr>
@@ -20730,7 +20730,7 @@
             <a:avLst/>
           </a:prstGeom>
           <a:solidFill>
-            <a:srgbClr val="5E7EA8"/>
+            <a:srgbClr val="4A5FC1"/>
           </a:solidFill>
           <a:ln>
             <a:noFill/>
@@ -20889,7 +20889,7 @@
             <a:r>
               <a:rPr sz="1800" b="1">
                 <a:solidFill>
-                  <a:srgbClr val="5E7EA8"/>
+                  <a:srgbClr val="4A5FC1"/>
                 </a:solidFill>
                 <a:latin typeface="Calibri"/>
               </a:rPr>
@@ -21022,7 +21022,7 @@
             <a:r>
               <a:rPr sz="1800" b="1">
                 <a:solidFill>
-                  <a:srgbClr val="4A6FA5"/>
+                  <a:srgbClr val="2E7DD1"/>
                 </a:solidFill>
                 <a:latin typeface="Calibri"/>
               </a:rPr>

</xml_diff>